<commit_message>
Deck: name Augmental VOX as the spark on "Why I built it"
Co-Authored-By: Claude Opus 5.5 <noreply@anthropic.com>
Claude-Session: https://claude.ai/code/session_0175b8PmKoLjH5BwXGg2hSmx
</commit_message>
<xml_diff>
--- a/docs/canti-overview.pptx
+++ b/docs/canti-overview.pptx
@@ -13418,7 +13418,7 @@
                 <a:ea typeface="IBM Plex Mono" pitchFamily="34" charset="-122"/>
                 <a:cs typeface="IBM Plex Mono" pitchFamily="34" charset="-120"/>
               </a:rPr>
-              <a:t>An AI service was selling a box that records your voice all day, and a dictation model sends it wherever you want.</a:t>
+              <a:t>Augmental's VOX: a mic pendant worn on the skin, so you can whisper to type. $200 in beta, shipping late 2026.</a:t>
             </a:r>
             <a:endParaRPr lang="en-US" sz="1100" dirty="0"/>
           </a:p>
@@ -13438,7 +13438,7 @@
                 <a:ea typeface="IBM Plex Mono" pitchFamily="34" charset="-122"/>
                 <a:cs typeface="IBM Plex Mono" pitchFamily="34" charset="-120"/>
               </a:rPr>
-              <a:t>It cost $200. But it is just a microphone pointed at yourself, so I built my own.</a:t>
+              <a:t>But it is just a microphone pointed at yourself, so I built my own.</a:t>
             </a:r>
             <a:endParaRPr lang="en-US" sz="1100" dirty="0"/>
           </a:p>
@@ -13453,7 +13453,7 @@
         <p:spPr>
           <a:xfrm>
             <a:off x="457200" y="2714625"/>
-            <a:ext cx="1714500" cy="228600"/>
+            <a:ext cx="2571750" cy="228600"/>
           </a:xfrm>
           <a:prstGeom prst="rect">
             <a:avLst/>
@@ -13477,7 +13477,7 @@
                 <a:ea typeface="Silkscreen" pitchFamily="34" charset="-122"/>
                 <a:cs typeface="Silkscreen" pitchFamily="34" charset="-120"/>
               </a:rPr>
-              <a:t>THEIR BOX</a:t>
+              <a:t>AUGMENTAL VOX</a:t>
             </a:r>
             <a:endParaRPr lang="en-US" sz="1800" dirty="0"/>
           </a:p>
@@ -13531,7 +13531,7 @@
         <p:spPr>
           <a:xfrm>
             <a:off x="457200" y="3400425"/>
-            <a:ext cx="1714500" cy="228600"/>
+            <a:ext cx="2571750" cy="228600"/>
           </a:xfrm>
           <a:prstGeom prst="rect">
             <a:avLst/>

</xml_diff>